<commit_message>
Preserve user saved model, audit Wi-Fi settings and update report evidence
</commit_message>
<xml_diff>
--- a/docs/Презентация_вариант_8.pptx
+++ b/docs/Презентация_вариант_8.pptx
@@ -3272,7 +3272,7 @@
               <a:defRPr sz="1000"/>
             </a:pPr>
             <a:r>
-              <a:t>ИТС · ДЗ № 1 · Вариант 8 · Проектный черновик | 1</a:t>
+              <a:t>ИТС · ДЗ № 1 · Вариант 8 · 1</a:t>
             </a:r>
           </a:p>
         </p:txBody>
@@ -3388,7 +3388,7 @@
               <a:defRPr sz="1000"/>
             </a:pPr>
             <a:r>
-              <a:t>ИТС · ДЗ № 1 · Вариант 8 · Проектный черновик | 10</a:t>
+              <a:t>ИТС · ДЗ № 1 · Вариант 8 · 10</a:t>
             </a:r>
           </a:p>
         </p:txBody>
@@ -3504,7 +3504,7 @@
               <a:defRPr sz="1000"/>
             </a:pPr>
             <a:r>
-              <a:t>ИТС · ДЗ № 1 · Вариант 8 · Проектный черновик | 11</a:t>
+              <a:t>ИТС · ДЗ № 1 · Вариант 8 · 11</a:t>
             </a:r>
           </a:p>
         </p:txBody>
@@ -3620,7 +3620,7 @@
               <a:defRPr sz="1000"/>
             </a:pPr>
             <a:r>
-              <a:t>ИТС · ДЗ № 1 · Вариант 8 · Проектный черновик | 12</a:t>
+              <a:t>ИТС · ДЗ № 1 · Вариант 8 · 12</a:t>
             </a:r>
           </a:p>
         </p:txBody>
@@ -3736,7 +3736,7 @@
               <a:defRPr sz="1000"/>
             </a:pPr>
             <a:r>
-              <a:t>ИТС · ДЗ № 1 · Вариант 8 · Проектный черновик | 13</a:t>
+              <a:t>ИТС · ДЗ № 1 · Вариант 8 · 13</a:t>
             </a:r>
           </a:p>
         </p:txBody>
@@ -3941,7 +3941,7 @@
               <a:defRPr sz="1000"/>
             </a:pPr>
             <a:r>
-              <a:t>ИТС · ДЗ № 1 · Вариант 8 · Проектный черновик | 14</a:t>
+              <a:t>ИТС · ДЗ № 1 · Вариант 8 · 14</a:t>
             </a:r>
           </a:p>
         </p:txBody>
@@ -4131,7 +4131,7 @@
               <a:defRPr sz="1000"/>
             </a:pPr>
             <a:r>
-              <a:t>ИТС · ДЗ № 1 · Вариант 8 · Проектный черновик | 15</a:t>
+              <a:t>ИТС · ДЗ № 1 · Вариант 8 · 15</a:t>
             </a:r>
           </a:p>
         </p:txBody>
@@ -4247,7 +4247,7 @@
               <a:defRPr sz="1000"/>
             </a:pPr>
             <a:r>
-              <a:t>ИТС · ДЗ № 1 · Вариант 8 · Проектный черновик | 16</a:t>
+              <a:t>ИТС · ДЗ № 1 · Вариант 8 · 16</a:t>
             </a:r>
           </a:p>
         </p:txBody>
@@ -4346,7 +4346,7 @@
               </a:defRPr>
             </a:pPr>
             <a:r>
-              <a:t>Обязательный .pkt и настоящий скриншот Packet Tracer ещё не получены.</a:t>
+              <a:t>Модель: packet-tracer/clinic8.pkt; Cisco Packet Tracer 8.2.2.0400.</a:t>
             </a:r>
           </a:p>
           <a:p>
@@ -4361,7 +4361,7 @@
               </a:defRPr>
             </a:pPr>
             <a:r>
-              <a:t>Подготовлены портовая ведомость, адресный план и конфигурации IOS.</a:t>
+              <a:t>84 ПК, 4 гостевых планшета, 112 кабелей; сохранены VLAN и WPA2/AES.</a:t>
             </a:r>
           </a:p>
           <a:p>
@@ -4376,7 +4376,7 @@
               </a:defRPr>
             </a:pPr>
             <a:r>
-              <a:t>Проверить: DHCP всех VLAN; межэтажный и межфилиальный доступ; HTTP, DNS, почту и NAT.</a:t>
+              <a:t>Пользователь подтвердил связь C2/B1/B2 с МИС и внешним сервером; B2 → B1.</a:t>
             </a:r>
           </a:p>
           <a:p>
@@ -4391,7 +4391,7 @@
               </a:defRPr>
             </a:pPr>
             <a:r>
-              <a:t>Проверить: запрет гостям доступа к медицинской сети и разрешение внешнего HTTP.</a:t>
+              <a:t>С B1 открыты три сайта по DNS-именам; доставлена почта B1 → C1 и C2 → B2.</a:t>
             </a:r>
           </a:p>
           <a:p>
@@ -4406,7 +4406,22 @@
               </a:defRPr>
             </a:pPr>
             <a:r>
-              <a:t>Эскиз предыдущего слайда нужно заменить скриншотом собранной модели.</a:t>
+              <a:t>На всех четырёх гостевых площадках внешний HTTP доступен, внутренний ICMP/HTTP заблокирован.</a:t>
+            </a:r>
+          </a:p>
+          <a:p>
+            <a:pPr>
+              <a:spcAft>
+                <a:spcPts val="1500"/>
+              </a:spcAft>
+              <a:defRPr sz="2300">
+                <a:solidFill>
+                  <a:srgbClr val="172C47"/>
+                </a:solidFill>
+              </a:defRPr>
+            </a:pPr>
+            <a:r>
+              <a:t>Нужен настоящий скриншот; на планшетах C1/B1 следует сохранить DHCP вместо Static.</a:t>
             </a:r>
           </a:p>
         </p:txBody>
@@ -4437,7 +4452,7 @@
               <a:defRPr sz="1000"/>
             </a:pPr>
             <a:r>
-              <a:t>ИТС · ДЗ № 1 · Вариант 8 · Проектный черновик | 17</a:t>
+              <a:t>ИТС · ДЗ № 1 · Вариант 8 · 17</a:t>
             </a:r>
           </a:p>
         </p:txBody>
@@ -4581,7 +4596,7 @@
               </a:defRPr>
             </a:pPr>
             <a:r>
-              <a:t>До сдачи: собрать и проверить .pkt, вставить скриншот, подтвердить цены и подтвердить комплектации.</a:t>
+              <a:t>Модель сохранена; выполненные пользователем проверки связи и служб зафиксированы.</a:t>
             </a:r>
           </a:p>
           <a:p>
@@ -4596,7 +4611,7 @@
               </a:defRPr>
             </a:pPr>
             <a:r>
-              <a:t>Подготовленный комплект пока является проектным черновиком.</a:t>
+              <a:t>Для завершения оформления: скриншот Cisco, DHCP планшетов C1/B1, подтверждение цен и комплектаций.</a:t>
             </a:r>
           </a:p>
         </p:txBody>
@@ -4627,7 +4642,7 @@
               <a:defRPr sz="1000"/>
             </a:pPr>
             <a:r>
-              <a:t>ИТС · ДЗ № 1 · Вариант 8 · Проектный черновик | 18</a:t>
+              <a:t>ИТС · ДЗ № 1 · Вариант 8 · 18</a:t>
             </a:r>
           </a:p>
         </p:txBody>
@@ -4802,7 +4817,7 @@
               <a:defRPr sz="1000"/>
             </a:pPr>
             <a:r>
-              <a:t>ИТС · ДЗ № 1 · Вариант 8 · Проектный черновик | 2</a:t>
+              <a:t>ИТС · ДЗ № 1 · Вариант 8 · 2</a:t>
             </a:r>
           </a:p>
         </p:txBody>
@@ -4918,7 +4933,7 @@
               <a:defRPr sz="1000"/>
             </a:pPr>
             <a:r>
-              <a:t>ИТС · ДЗ № 1 · Вариант 8 · Проектный черновик | 3</a:t>
+              <a:t>ИТС · ДЗ № 1 · Вариант 8 · 3</a:t>
             </a:r>
           </a:p>
         </p:txBody>
@@ -5034,7 +5049,7 @@
               <a:defRPr sz="1000"/>
             </a:pPr>
             <a:r>
-              <a:t>ИТС · ДЗ № 1 · Вариант 8 · Проектный черновик | 4</a:t>
+              <a:t>ИТС · ДЗ № 1 · Вариант 8 · 4</a:t>
             </a:r>
           </a:p>
         </p:txBody>
@@ -5224,7 +5239,7 @@
               <a:defRPr sz="1000"/>
             </a:pPr>
             <a:r>
-              <a:t>ИТС · ДЗ № 1 · Вариант 8 · Проектный черновик | 5</a:t>
+              <a:t>ИТС · ДЗ № 1 · Вариант 8 · 5</a:t>
             </a:r>
           </a:p>
         </p:txBody>
@@ -5399,7 +5414,7 @@
               <a:defRPr sz="1000"/>
             </a:pPr>
             <a:r>
-              <a:t>ИТС · ДЗ № 1 · Вариант 8 · Проектный черновик | 6</a:t>
+              <a:t>ИТС · ДЗ № 1 · Вариант 8 · 6</a:t>
             </a:r>
           </a:p>
         </p:txBody>
@@ -5604,7 +5619,7 @@
               <a:defRPr sz="1000"/>
             </a:pPr>
             <a:r>
-              <a:t>ИТС · ДЗ № 1 · Вариант 8 · Проектный черновик | 7</a:t>
+              <a:t>ИТС · ДЗ № 1 · Вариант 8 · 7</a:t>
             </a:r>
           </a:p>
         </p:txBody>
@@ -5809,7 +5824,7 @@
               <a:defRPr sz="1000"/>
             </a:pPr>
             <a:r>
-              <a:t>ИТС · ДЗ № 1 · Вариант 8 · Проектный черновик | 8</a:t>
+              <a:t>ИТС · ДЗ № 1 · Вариант 8 · 8</a:t>
             </a:r>
           </a:p>
         </p:txBody>
@@ -6014,7 +6029,7 @@
               <a:defRPr sz="1000"/>
             </a:pPr>
             <a:r>
-              <a:t>ИТС · ДЗ № 1 · Вариант 8 · Проектный черновик | 9</a:t>
+              <a:t>ИТС · ДЗ № 1 · Вариант 8 · 9</a:t>
             </a:r>
           </a:p>
         </p:txBody>

</xml_diff>

<commit_message>
Accept final user model with DHCP on all guest tablets and update documents
</commit_message>
<xml_diff>
--- a/docs/Презентация_вариант_8.pptx
+++ b/docs/Презентация_вариант_8.pptx
@@ -4421,7 +4421,7 @@
               </a:defRPr>
             </a:pPr>
             <a:r>
-              <a:t>Нужен настоящий скриншот; на планшетах C1/B1 следует сохранить DHCP вместо Static.</a:t>
+              <a:t>На всех четырёх гостевых планшетах сохранён DHCP. Скриншот модели ожидается отдельным файлом.</a:t>
             </a:r>
           </a:p>
         </p:txBody>
@@ -4611,7 +4611,7 @@
               </a:defRPr>
             </a:pPr>
             <a:r>
-              <a:t>Для завершения оформления: скриншот Cisco, DHCP планшетов C1/B1, подтверждение цен и комплектаций.</a:t>
+              <a:t>Для завершения оформления: скриншот Cisco, подтверждение цен и комплектаций.</a:t>
             </a:r>
           </a:p>
         </p:txBody>

</xml_diff>

<commit_message>
Embed authentic user Cisco overview screenshot in report and presentation
</commit_message>
<xml_diff>
--- a/docs/Презентация_вариант_8.pptx
+++ b/docs/Презентация_вариант_8.pptx
@@ -4192,14 +4192,14 @@
               </a:defRPr>
             </a:pPr>
             <a:r>
-              <a:t>13. Логическая схема — проектный эскиз</a:t>
+              <a:t>13. Логическая схема Cisco Packet Tracer</a:t>
             </a:r>
           </a:p>
         </p:txBody>
       </p:sp>
       <p:pic>
         <p:nvPicPr>
-          <p:cNvPr id="3" name="Picture 2" descr="logical-draft.png"/>
+          <p:cNvPr id="3" name="Picture 2" descr="packet-tracer.png"/>
           <p:cNvPicPr>
             <a:picLocks noChangeAspect="1"/>
           </p:cNvPicPr>
@@ -4213,8 +4213,8 @@
         </p:blipFill>
         <p:spPr>
           <a:xfrm>
-            <a:off x="3977468" y="1051560"/>
-            <a:ext cx="4236758" cy="5120640"/>
+            <a:off x="825840" y="1051560"/>
+            <a:ext cx="10540013" cy="5120640"/>
           </a:xfrm>
           <a:prstGeom prst="rect">
             <a:avLst/>
@@ -4421,7 +4421,7 @@
               </a:defRPr>
             </a:pPr>
             <a:r>
-              <a:t>На всех четырёх гостевых планшетах сохранён DHCP. Скриншот модели ожидается отдельным файлом.</a:t>
+              <a:t>На всех четырёх гостевых планшетах сохранён DHCP. Общий вид модели приведён на предыдущем слайде.</a:t>
             </a:r>
           </a:p>
         </p:txBody>
@@ -4611,7 +4611,7 @@
               </a:defRPr>
             </a:pPr>
             <a:r>
-              <a:t>Для завершения оформления: скриншот Cisco, подтверждение цен и комплектаций.</a:t>
+              <a:t>Для завершения сметы: подтверждение рыночных цен и комплектаций.</a:t>
             </a:r>
           </a:p>
         </p:txBody>

</xml_diff>

<commit_message>
Revise clinic homework materials for L1-L2 scope and ruble-only budget
</commit_message>
<xml_diff>
--- a/docs/Презентация_вариант_8.pptx
+++ b/docs/Презентация_вариант_8.pptx
@@ -4780,7 +4780,7 @@
                 </a:solidFill>
                 <a:latin typeface="ALS Sector Regular"/>
               </a:rPr>
-              <a:t>99 линий Cat6:</a:t>
+              <a:t>96 постоянных линий Cat6:</a:t>
             </a:r>
             <a:r>
               <a:rPr sz="1900">
@@ -4789,7 +4789,7 @@
                 </a:solidFill>
                 <a:latin typeface="ALS Sector Regular"/>
               </a:rPr>
-              <a:t> 2868.4 м; с 20% запасом: 3442.1 м.</a:t>
+              <a:t> 2904.8 м; с 20% запасом: 3485.8 м.</a:t>
             </a:r>
           </a:p>
         </p:txBody>
@@ -5071,7 +5071,7 @@
                 </a:solidFill>
                 <a:latin typeface="ALS Sector Regular"/>
               </a:rPr>
-              <a:t> 46.8 м; ограничения 90/100 м соблюдены.</a:t>
+              <a:t> 48.8 м; ограничения 90/100 м соблюдены.</a:t>
             </a:r>
           </a:p>
         </p:txBody>
@@ -5414,7 +5414,7 @@
               </a:defRPr>
             </a:pPr>
             <a:r>
-              <a:t>9 061 750 ₽.</a:t>
+              <a:t>7 907 116 ₽.</a:t>
             </a:r>
           </a:p>
         </p:txBody>
@@ -5544,7 +5544,22 @@
               </a:defRPr>
             </a:pPr>
             <a:r>
-              <a:t>Цены приняты ориентировочно для оценки бюджета проекта.</a:t>
+              <a:rPr sz="1900">
+                <a:solidFill>
+                  <a:srgbClr val="176DEA"/>
+                </a:solidFill>
+                <a:latin typeface="ALS Sector Regular"/>
+              </a:rPr>
+              <a:t>Сетевое оборудование:</a:t>
+            </a:r>
+            <a:r>
+              <a:rPr sz="1900">
+                <a:solidFill>
+                  <a:srgbClr val="434343"/>
+                </a:solidFill>
+                <a:latin typeface="ALS Sector Regular"/>
+              </a:rPr>
+              <a:t> каталоговые цены. Остальные позиции: предварительная оценка.</a:t>
             </a:r>
           </a:p>
         </p:txBody>
@@ -5836,14 +5851,14 @@
               </a:defRPr>
             </a:pPr>
             <a:r>
-              <a:t>13. Логическая схема Cisco Packet Tracer</a:t>
+              <a:t>13. Схема связей и функциональных групп</a:t>
             </a:r>
           </a:p>
         </p:txBody>
       </p:sp>
       <p:pic>
         <p:nvPicPr>
-          <p:cNvPr id="3" name="Picture 2" descr="packet-tracer.png"/>
+          <p:cNvPr id="3" name="Picture 2" descr="logical-draft.png"/>
           <p:cNvPicPr>
             <a:picLocks noChangeAspect="1"/>
           </p:cNvPicPr>
@@ -5857,8 +5872,8 @@
         </p:blipFill>
         <p:spPr>
           <a:xfrm>
-            <a:off x="995234" y="1499616"/>
-            <a:ext cx="10201227" cy="4956048"/>
+            <a:off x="2040899" y="1499616"/>
+            <a:ext cx="8109896" cy="4956048"/>
           </a:xfrm>
           <a:prstGeom prst="rect">
             <a:avLst/>
@@ -5994,7 +6009,7 @@
               </a:defRPr>
             </a:pPr>
             <a:r>
-              <a:t>13. Файл Cisco и результаты моделирования</a:t>
+              <a:t>13. Модель Cisco Packet Tracer L1–L2</a:t>
             </a:r>
           </a:p>
         </p:txBody>
@@ -6073,7 +6088,22 @@
               </a:defRPr>
             </a:pPr>
             <a:r>
-              <a:t>Модель clinic8.pkt · Cisco Packet Tracer 8.2.2.0400.</a:t>
+              <a:rPr sz="1900">
+                <a:solidFill>
+                  <a:srgbClr val="176DEA"/>
+                </a:solidFill>
+                <a:latin typeface="ALS Sector Regular"/>
+              </a:rPr>
+              <a:t>Файл:</a:t>
+            </a:r>
+            <a:r>
+              <a:rPr sz="1900">
+                <a:solidFill>
+                  <a:srgbClr val="434343"/>
+                </a:solidFill>
+                <a:latin typeface="ALS Sector Regular"/>
+              </a:rPr>
+              <a:t> clinic8-L1-L2.pkt.</a:t>
             </a:r>
           </a:p>
         </p:txBody>
@@ -6109,7 +6139,7 @@
               </a:defRPr>
             </a:pPr>
             <a:r>
-              <a:t>84 ПК, 4 гостевых планшета, 112 кабелей; сохранены VLAN и WPA2/AES.</a:t>
+              <a:t>Сохранены устройства, расположение и кабельные соединения.</a:t>
             </a:r>
           </a:p>
         </p:txBody>
@@ -6188,7 +6218,7 @@
               </a:defRPr>
             </a:pPr>
             <a:r>
-              <a:t>Проверена связь C2/B1/B2 с МИС и внешним сервером; B2 → B1.</a:t>
+              <a:t>84 ПК, 8 МФУ, 4 AP и 3 сервера поликлиники.</a:t>
             </a:r>
           </a:p>
         </p:txBody>
@@ -6267,7 +6297,7 @@
               </a:defRPr>
             </a:pPr>
             <a:r>
-              <a:t>С B1 открыты три сайта по DNS-именам; доставлена почта B1 → C1 и C2 → B2.</a:t>
+              <a:t>Дополнительно показаны сеть оператора и 4 гостевых планшета.</a:t>
             </a:r>
           </a:p>
         </p:txBody>
@@ -6346,7 +6376,7 @@
               </a:defRPr>
             </a:pPr>
             <a:r>
-              <a:t>На всех четырёх гостевых площадках внешний HTTP доступен, внутренний ICMP/HTTP заблокирован.</a:t>
+              <a:t>Настройки адресации, маршрутизации и сетевых служб отсутствуют.</a:t>
             </a:r>
           </a:p>
         </p:txBody>
@@ -6425,7 +6455,7 @@
               </a:defRPr>
             </a:pPr>
             <a:r>
-              <a:t>На всех четырёх гостевых планшетах сохранён DHCP. Общий вид модели приведён на предыдущем слайде.</a:t>
+              <a:t>Модель предназначена для представления структуры, размещения и соединений оборудования.</a:t>
             </a:r>
           </a:p>
         </p:txBody>
@@ -6644,7 +6674,7 @@
                 </a:solidFill>
                 <a:latin typeface="ALS Sector Regular"/>
               </a:rPr>
-              <a:t>Разработан проект сети трёх площадок:</a:t>
+              <a:t>Разработан проект трёх площадок:</a:t>
             </a:r>
             <a:r>
               <a:rPr sz="1900">
@@ -6653,7 +6683,7 @@
                 </a:solidFill>
                 <a:latin typeface="ALS Sector Regular"/>
               </a:rPr>
-              <a:t> 112 сотрудников, 84 ПК, 99 подключений.</a:t>
+              <a:t> 112 сотрудников, 84 рабочих станции.</a:t>
             </a:r>
           </a:p>
         </p:txBody>
@@ -6689,7 +6719,22 @@
               </a:defRPr>
             </a:pPr>
             <a:r>
-              <a:t>Рассчитаны пиковая нагрузка, кабельные трассы и предварительная смета.</a:t>
+              <a:rPr sz="1900">
+                <a:solidFill>
+                  <a:srgbClr val="176DEA"/>
+                </a:solidFill>
+                <a:latin typeface="ALS Sector Regular"/>
+              </a:rPr>
+              <a:t>Концепция:</a:t>
+            </a:r>
+            <a:r>
+              <a:rPr sz="1900">
+                <a:solidFill>
+                  <a:srgbClr val="434343"/>
+                </a:solidFill>
+                <a:latin typeface="ALS Sector Regular"/>
+              </a:rPr>
+              <a:t> единый диагностический архив и общая медицинская история.</a:t>
             </a:r>
           </a:p>
         </p:txBody>
@@ -6768,7 +6813,7 @@
               </a:defRPr>
             </a:pPr>
             <a:r>
-              <a:t>Согласованы этажная маршрутизация, гостевые сегменты и серверные службы.</a:t>
+              <a:t>Рассчитаны нагрузки, кабельные трассы и резерв расширения.</a:t>
             </a:r>
           </a:p>
         </p:txBody>
@@ -6847,7 +6892,7 @@
               </a:defRPr>
             </a:pPr>
             <a:r>
-              <a:t>В модели проверены связь между площадками, серверные службы и гостевая изоляция.</a:t>
+              <a:t>Выбраны гигабитные подключения, межэтажная оптика и каналы филиалов.</a:t>
             </a:r>
           </a:p>
         </p:txBody>
@@ -6926,21 +6971,64 @@
               </a:defRPr>
             </a:pPr>
             <a:r>
-              <a:t>Ориентировочная стоимость оборудования и кабельных материалов: 9 061 750 ₽.</a:t>
-            </a:r>
-          </a:p>
-        </p:txBody>
-      </p:sp>
-      <p:sp>
-        <p:nvSpPr>
-          <p:cNvPr id="12" name="TextBox 11"/>
+              <a:t>Составлена физическая модель без настройки сетевых служб.</a:t>
+            </a:r>
+          </a:p>
+        </p:txBody>
+      </p:sp>
+      <p:sp>
+        <p:nvSpPr>
+          <p:cNvPr id="12" name="Rectangle 11"/>
+          <p:cNvSpPr/>
+          <p:nvPr/>
+        </p:nvSpPr>
+        <p:spPr>
+          <a:xfrm>
+            <a:off x="6437376" y="4824984"/>
+            <a:ext cx="4965192" cy="10972"/>
+          </a:xfrm>
+          <a:prstGeom prst="rect">
+            <a:avLst/>
+          </a:prstGeom>
+          <a:solidFill>
+            <a:srgbClr val="D9D9D9"/>
+          </a:solidFill>
+          <a:ln>
+            <a:noFill/>
+          </a:ln>
+        </p:spPr>
+        <p:style>
+          <a:lnRef idx="1">
+            <a:schemeClr val="accent1"/>
+          </a:lnRef>
+          <a:fillRef idx="3">
+            <a:schemeClr val="accent1"/>
+          </a:fillRef>
+          <a:effectRef idx="2">
+            <a:schemeClr val="accent1"/>
+          </a:effectRef>
+          <a:fontRef idx="minor">
+            <a:schemeClr val="lt1"/>
+          </a:fontRef>
+        </p:style>
+        <p:txBody>
+          <a:bodyPr rtlCol="0" anchor="ctr"/>
+          <a:lstStyle/>
+          <a:p>
+            <a:pPr algn="ctr"/>
+          </a:p>
+        </p:txBody>
+      </p:sp>
+      <p:sp>
+        <p:nvSpPr>
+          <p:cNvPr id="13" name="TextBox 12"/>
           <p:cNvSpPr txBox="1"/>
           <p:nvPr/>
         </p:nvSpPr>
         <p:spPr>
           <a:xfrm>
-            <a:off x="694944" y="6565392"/>
-            <a:ext cx="9144000" cy="164592"/>
+            <a:off x="6437376" y="4934712"/>
+            <a:ext cx="4965192" cy="1420368"/>
           </a:xfrm>
           <a:prstGeom prst="rect">
             <a:avLst/>
@@ -6954,6 +7042,57 @@
           <a:lstStyle/>
           <a:p>
             <a:pPr>
+              <a:defRPr b="0" sz="1900">
+                <a:solidFill>
+                  <a:srgbClr val="434343"/>
+                </a:solidFill>
+                <a:latin typeface="ALS Sector Regular"/>
+              </a:defRPr>
+            </a:pPr>
+            <a:r>
+              <a:rPr sz="1900">
+                <a:solidFill>
+                  <a:srgbClr val="176DEA"/>
+                </a:solidFill>
+                <a:latin typeface="ALS Sector Regular"/>
+              </a:rPr>
+              <a:t>Стоимость оборудования и кабельных материалов:</a:t>
+            </a:r>
+            <a:r>
+              <a:rPr sz="1900">
+                <a:solidFill>
+                  <a:srgbClr val="434343"/>
+                </a:solidFill>
+                <a:latin typeface="ALS Sector Regular"/>
+              </a:rPr>
+              <a:t> 7 907 116 ₽.</a:t>
+            </a:r>
+          </a:p>
+        </p:txBody>
+      </p:sp>
+      <p:sp>
+        <p:nvSpPr>
+          <p:cNvPr id="14" name="TextBox 13"/>
+          <p:cNvSpPr txBox="1"/>
+          <p:nvPr/>
+        </p:nvSpPr>
+        <p:spPr>
+          <a:xfrm>
+            <a:off x="694944" y="6565392"/>
+            <a:ext cx="9144000" cy="164592"/>
+          </a:xfrm>
+          <a:prstGeom prst="rect">
+            <a:avLst/>
+          </a:prstGeom>
+          <a:noFill/>
+        </p:spPr>
+        <p:txBody>
+          <a:bodyPr wrap="square" lIns="0" rIns="0" tIns="0" bIns="0">
+            <a:spAutoFit/>
+          </a:bodyPr>
+          <a:lstStyle/>
+          <a:p>
+            <a:pPr>
               <a:defRPr b="0" sz="900">
                 <a:solidFill>
                   <a:srgbClr val="A1A1A3"/>
@@ -6969,7 +7108,7 @@
       </p:sp>
       <p:sp>
         <p:nvSpPr>
-          <p:cNvPr id="13" name="TextBox 12"/>
+          <p:cNvPr id="15" name="TextBox 14"/>
           <p:cNvSpPr txBox="1"/>
           <p:nvPr/>
         </p:nvSpPr>
@@ -8692,22 +8831,7 @@
               </a:defRPr>
             </a:pPr>
             <a:r>
-              <a:rPr sz="1900">
-                <a:solidFill>
-                  <a:srgbClr val="176DEA"/>
-                </a:solidFill>
-                <a:latin typeface="ALS Sector Regular"/>
-              </a:rPr>
-              <a:t>В Packet Tracer:</a:t>
-            </a:r>
-            <a:r>
-              <a:rPr sz="1900">
-                <a:solidFill>
-                  <a:srgbClr val="434343"/>
-                </a:solidFill>
-                <a:latin typeface="ALS Sector Regular"/>
-              </a:rPr>
-              <a:t> только учебная имитация HTTP, DNS и EMAIL; МИС/PACS не развёртываются.</a:t>
+              <a:t>ПО определяет требования к сети. Модель ДЗ1 содержит оборудование и линии связи без настройки служб.</a:t>
             </a:r>
           </a:p>
         </p:txBody>
@@ -10509,7 +10633,7 @@
                 </a:solidFill>
                 <a:latin typeface="ALS Sector Regular"/>
               </a:rPr>
-              <a:t>Ориентиры:</a:t>
+              <a:t>Модели:</a:t>
             </a:r>
             <a:r>
               <a:rPr sz="1900">
@@ -10518,7 +10642,7 @@
                 </a:solidFill>
                 <a:latin typeface="ALS Sector Regular"/>
               </a:rPr>
-              <a:t> Cisco C1111-8P, CBS350-24P-4G, TP-Link EAP610.</a:t>
+              <a:t> MikroTik RB5009UG+S+IN, CRS328-24P-4S+RM, cAP ax.</a:t>
             </a:r>
           </a:p>
         </p:txBody>
@@ -10597,7 +10721,7 @@
               </a:defRPr>
             </a:pPr>
             <a:r>
-              <a:t>Модельные ориентиры и ориентировочная стоимость приведены в расчётном приложении.</a:t>
+              <a:t>Характеристики и стоимость по каждой позиции приведены в расчётном приложении.</a:t>
             </a:r>
           </a:p>
         </p:txBody>

</xml_diff>

<commit_message>
Add confirmed Cisco L1-L2 overview to presentation and submission package
</commit_message>
<xml_diff>
--- a/docs/Презентация_вариант_8.pptx
+++ b/docs/Презентация_вариант_8.pptx
@@ -5851,14 +5851,14 @@
               </a:defRPr>
             </a:pPr>
             <a:r>
-              <a:t>13. Схема связей и функциональных групп</a:t>
+              <a:t>13. Общий вид сети в Cisco Packet Tracer</a:t>
             </a:r>
           </a:p>
         </p:txBody>
       </p:sp>
       <p:pic>
         <p:nvPicPr>
-          <p:cNvPr id="3" name="Picture 2" descr="logical-draft.png"/>
+          <p:cNvPr id="3" name="Picture 2" descr="packet-tracer-l1l2.png"/>
           <p:cNvPicPr>
             <a:picLocks noChangeAspect="1"/>
           </p:cNvPicPr>
@@ -5872,8 +5872,8 @@
         </p:blipFill>
         <p:spPr>
           <a:xfrm>
-            <a:off x="2040899" y="1499616"/>
-            <a:ext cx="8109896" cy="4956048"/>
+            <a:off x="2295745" y="1499616"/>
+            <a:ext cx="7600204" cy="4956048"/>
           </a:xfrm>
           <a:prstGeom prst="rect">
             <a:avLst/>

</xml_diff>